<commit_message>
docs: 일일 보고서 자동 생성 (2026-05-08)
</commit_message>
<xml_diff>
--- a/docs/daily-reports/roadmap_20260508.pptx
+++ b/docs/daily-reports/roadmap_20260508.pptx
@@ -1061,7 +1061,7 @@
                 <a:ea typeface="Arial" pitchFamily="34" charset="-122"/>
                 <a:cs typeface="Arial" pitchFamily="34" charset="-120"/>
               </a:rPr>
-              <a:t>2026-05-07  |  v2.8.0</a:t>
+              <a:t>2026-05-08  |  v2.8.2</a:t>
             </a:r>
             <a:endParaRPr lang="en-US" sz="1000" dirty="0"/>
           </a:p>
@@ -2894,7 +2894,7 @@
                 <a:ea typeface="Arial" pitchFamily="34" charset="-122"/>
                 <a:cs typeface="Arial" pitchFamily="34" charset="-120"/>
               </a:rPr>
-              <a:t>v2.8.0</a:t>
+              <a:t>v2.8.2</a:t>
             </a:r>
             <a:endParaRPr lang="en-US" sz="2000" dirty="0"/>
           </a:p>
@@ -3380,7 +3380,7 @@
                 <a:ea typeface="Arial" pitchFamily="34" charset="-122"/>
                 <a:cs typeface="Arial" pitchFamily="34" charset="-120"/>
               </a:rPr>
-              <a:t>2026-05-07</a:t>
+              <a:t>2026-05-08</a:t>
             </a:r>
             <a:endParaRPr lang="en-US" sz="1000" dirty="0"/>
           </a:p>

</xml_diff>